<commit_message>
Set conservative base yield 1,400 poles/ha (was 2,000)
Rationale: Be defensible to investors. Published research shows Guadua
bamboo yields range widely (800-3,000 poles/ha). We use 1,400 as base
case — comfortably within realistic range, not overly optimistic.

Changes:
- Excel Assumptions B4-B6: yr5=350, yr6=700, yr7+=1,400 (was 500/1000/2000)
- Base 10 ha steady state remains 14,000 poles (10 × 1,400) — consistent
- Full 110 ha maturity: 154,000 poles/year (was 220,000)
- Revenue 2038: 52M MXN (was 73M) — more defensible

Sensitivity scenarios (PPTX + HTML):
- Conservative: 1,000/ha — downside protection
- Base Case ⭐: 1,400/ha — OUR PROJECTION
- Optimistic: 2,000-3,000/ha — possible upside

Prominently noted on Financial Projections and Sensitivity slides.

Co-Authored-By: Claude Opus 4.6 (1M context) <noreply@anthropic.com>
</commit_message>
<xml_diff>
--- a/Pacifico_Bambu_Pitch_Deck_v3.pptx
+++ b/Pacifico_Bambu_Pitch_Deck_v3.pptx
@@ -5910,7 +5910,7 @@
               </a:defRPr>
             </a:pPr>
             <a:r>
-              <a:t>Conservative projections: 110 ha at maturity, 2,000 poles/ha mature yield, 400 MXN/pole.</a:t>
+              <a:t>CONSERVATIVE BASE: 110 ha at maturity, 1,400 poles/ha mature yield, 400 MXN/pole. Options: 1K / 2K / 3K.</a:t>
             </a:r>
           </a:p>
         </p:txBody>
@@ -6240,8 +6240,8 @@
         </p:nvSpPr>
         <p:spPr>
           <a:xfrm>
-            <a:off x="2834640" y="5475428"/>
-            <a:ext cx="548640" cy="102412"/>
+            <a:off x="2834640" y="5501031"/>
+            <a:ext cx="548640" cy="76809"/>
           </a:xfrm>
           <a:prstGeom prst="roundRect">
             <a:avLst>
@@ -6249,7 +6249,7 @@
             </a:avLst>
           </a:prstGeom>
           <a:solidFill>
-            <a:srgbClr val="2D4537"/>
+            <a:srgbClr val="2D4435"/>
           </a:solidFill>
           <a:ln>
             <a:noFill/>
@@ -6285,7 +6285,7 @@
         </p:nvSpPr>
         <p:spPr>
           <a:xfrm>
-            <a:off x="2743200" y="5246828"/>
+            <a:off x="2743200" y="5272431"/>
             <a:ext cx="731520" cy="228600"/>
           </a:xfrm>
           <a:prstGeom prst="rect">
@@ -6308,7 +6308,7 @@
               </a:defRPr>
             </a:pPr>
             <a:r>
-              <a:t>1M</a:t>
+              <a:t>680K</a:t>
             </a:r>
           </a:p>
         </p:txBody>
@@ -6357,7 +6357,124 @@
         </p:nvSpPr>
         <p:spPr>
           <a:xfrm>
-            <a:off x="3657600" y="5424221"/>
+            <a:off x="3657600" y="5449824"/>
+            <a:ext cx="548640" cy="128016"/>
+          </a:xfrm>
+          <a:prstGeom prst="roundRect">
+            <a:avLst>
+              <a:gd name="adj" fmla="val 15000"/>
+            </a:avLst>
+          </a:prstGeom>
+          <a:solidFill>
+            <a:srgbClr val="2D4738"/>
+          </a:solidFill>
+          <a:ln>
+            <a:noFill/>
+          </a:ln>
+        </p:spPr>
+        <p:style>
+          <a:lnRef idx="1">
+            <a:schemeClr val="accent1"/>
+          </a:lnRef>
+          <a:fillRef idx="3">
+            <a:schemeClr val="accent1"/>
+          </a:fillRef>
+          <a:effectRef idx="2">
+            <a:schemeClr val="accent1"/>
+          </a:effectRef>
+          <a:fontRef idx="minor">
+            <a:schemeClr val="lt1"/>
+          </a:fontRef>
+        </p:style>
+        <p:txBody>
+          <a:bodyPr rtlCol="0" anchor="ctr"/>
+          <a:lstStyle/>
+          <a:p>
+            <a:pPr algn="ctr"/>
+          </a:p>
+        </p:txBody>
+      </p:sp>
+      <p:sp>
+        <p:nvSpPr>
+          <p:cNvPr id="17" name="TextBox 16"/>
+          <p:cNvSpPr txBox="1"/>
+          <p:nvPr/>
+        </p:nvSpPr>
+        <p:spPr>
+          <a:xfrm>
+            <a:off x="3566160" y="5221224"/>
+            <a:ext cx="731520" cy="228600"/>
+          </a:xfrm>
+          <a:prstGeom prst="rect">
+            <a:avLst/>
+          </a:prstGeom>
+          <a:noFill/>
+        </p:spPr>
+        <p:txBody>
+          <a:bodyPr wrap="square">
+            <a:spAutoFit/>
+          </a:bodyPr>
+          <a:lstStyle/>
+          <a:p>
+            <a:pPr algn="ctr">
+              <a:defRPr sz="800" b="0">
+                <a:solidFill>
+                  <a:srgbClr val="999999"/>
+                </a:solidFill>
+                <a:latin typeface="Calibri"/>
+              </a:defRPr>
+            </a:pPr>
+            <a:r>
+              <a:t>1M</a:t>
+            </a:r>
+          </a:p>
+        </p:txBody>
+      </p:sp>
+      <p:sp>
+        <p:nvSpPr>
+          <p:cNvPr id="18" name="TextBox 17"/>
+          <p:cNvSpPr txBox="1"/>
+          <p:nvPr/>
+        </p:nvSpPr>
+        <p:spPr>
+          <a:xfrm>
+            <a:off x="3611880" y="5669280"/>
+            <a:ext cx="640080" cy="228600"/>
+          </a:xfrm>
+          <a:prstGeom prst="rect">
+            <a:avLst/>
+          </a:prstGeom>
+          <a:noFill/>
+        </p:spPr>
+        <p:txBody>
+          <a:bodyPr wrap="square">
+            <a:spAutoFit/>
+          </a:bodyPr>
+          <a:lstStyle/>
+          <a:p>
+            <a:pPr algn="ctr">
+              <a:defRPr sz="800" b="0">
+                <a:solidFill>
+                  <a:srgbClr val="666666"/>
+                </a:solidFill>
+                <a:latin typeface="Calibri"/>
+              </a:defRPr>
+            </a:pPr>
+            <a:r>
+              <a:t>2029</a:t>
+            </a:r>
+          </a:p>
+        </p:txBody>
+      </p:sp>
+      <p:sp>
+        <p:nvSpPr>
+          <p:cNvPr id="19" name="Rounded Rectangle 18"/>
+          <p:cNvSpPr/>
+          <p:nvPr/>
+        </p:nvSpPr>
+        <p:spPr>
+          <a:xfrm>
+            <a:off x="4480560" y="5424221"/>
             <a:ext cx="548640" cy="153619"/>
           </a:xfrm>
           <a:prstGeom prst="roundRect">
@@ -6396,13 +6513,13 @@
       </p:sp>
       <p:sp>
         <p:nvSpPr>
-          <p:cNvPr id="17" name="TextBox 16"/>
-          <p:cNvSpPr txBox="1"/>
-          <p:nvPr/>
-        </p:nvSpPr>
-        <p:spPr>
-          <a:xfrm>
-            <a:off x="3566160" y="5195621"/>
+          <p:cNvPr id="20" name="TextBox 19"/>
+          <p:cNvSpPr txBox="1"/>
+          <p:nvPr/>
+        </p:nvSpPr>
+        <p:spPr>
+          <a:xfrm>
+            <a:off x="4389120" y="5195621"/>
             <a:ext cx="731520" cy="228600"/>
           </a:xfrm>
           <a:prstGeom prst="rect">
@@ -6417,28 +6534,28 @@
           <a:lstStyle/>
           <a:p>
             <a:pPr algn="ctr">
-              <a:defRPr sz="800" b="0">
-                <a:solidFill>
-                  <a:srgbClr val="999999"/>
-                </a:solidFill>
-                <a:latin typeface="Calibri"/>
-              </a:defRPr>
-            </a:pPr>
-            <a:r>
-              <a:t>2M</a:t>
-            </a:r>
-          </a:p>
-        </p:txBody>
-      </p:sp>
-      <p:sp>
-        <p:nvSpPr>
-          <p:cNvPr id="18" name="TextBox 17"/>
-          <p:cNvSpPr txBox="1"/>
-          <p:nvPr/>
-        </p:nvSpPr>
-        <p:spPr>
-          <a:xfrm>
-            <a:off x="3611880" y="5669280"/>
+              <a:defRPr sz="800" b="1">
+                <a:solidFill>
+                  <a:srgbClr val="2DD4A8"/>
+                </a:solidFill>
+                <a:latin typeface="Calibri"/>
+              </a:defRPr>
+            </a:pPr>
+            <a:r>
+              <a:t>1M</a:t>
+            </a:r>
+          </a:p>
+        </p:txBody>
+      </p:sp>
+      <p:sp>
+        <p:nvSpPr>
+          <p:cNvPr id="21" name="TextBox 20"/>
+          <p:cNvSpPr txBox="1"/>
+          <p:nvPr/>
+        </p:nvSpPr>
+        <p:spPr>
+          <a:xfrm>
+            <a:off x="4434840" y="5669280"/>
             <a:ext cx="640080" cy="228600"/>
           </a:xfrm>
           <a:prstGeom prst="rect">
@@ -6453,29 +6570,29 @@
           <a:lstStyle/>
           <a:p>
             <a:pPr algn="ctr">
-              <a:defRPr sz="800" b="0">
-                <a:solidFill>
-                  <a:srgbClr val="666666"/>
-                </a:solidFill>
-                <a:latin typeface="Calibri"/>
-              </a:defRPr>
-            </a:pPr>
-            <a:r>
-              <a:t>2029</a:t>
-            </a:r>
-          </a:p>
-        </p:txBody>
-      </p:sp>
-      <p:sp>
-        <p:nvSpPr>
-          <p:cNvPr id="19" name="Rounded Rectangle 18"/>
+              <a:defRPr sz="800" b="1">
+                <a:solidFill>
+                  <a:srgbClr val="2DD4A8"/>
+                </a:solidFill>
+                <a:latin typeface="Calibri"/>
+              </a:defRPr>
+            </a:pPr>
+            <a:r>
+              <a:t>2030</a:t>
+            </a:r>
+          </a:p>
+        </p:txBody>
+      </p:sp>
+      <p:sp>
+        <p:nvSpPr>
+          <p:cNvPr id="22" name="Rounded Rectangle 21"/>
           <p:cNvSpPr/>
           <p:nvPr/>
         </p:nvSpPr>
         <p:spPr>
           <a:xfrm>
-            <a:off x="4480560" y="5321808"/>
-            <a:ext cx="548640" cy="256032"/>
+            <a:off x="5303520" y="5116983"/>
+            <a:ext cx="548640" cy="460857"/>
           </a:xfrm>
           <a:prstGeom prst="roundRect">
             <a:avLst>
@@ -6483,7 +6600,7 @@
             </a:avLst>
           </a:prstGeom>
           <a:solidFill>
-            <a:srgbClr val="2D4E3E"/>
+            <a:srgbClr val="2D5A47"/>
           </a:solidFill>
           <a:ln>
             <a:noFill/>
@@ -6513,13 +6630,13 @@
       </p:sp>
       <p:sp>
         <p:nvSpPr>
-          <p:cNvPr id="20" name="TextBox 19"/>
-          <p:cNvSpPr txBox="1"/>
-          <p:nvPr/>
-        </p:nvSpPr>
-        <p:spPr>
-          <a:xfrm>
-            <a:off x="4389120" y="5093208"/>
+          <p:cNvPr id="23" name="TextBox 22"/>
+          <p:cNvSpPr txBox="1"/>
+          <p:nvPr/>
+        </p:nvSpPr>
+        <p:spPr>
+          <a:xfrm>
+            <a:off x="5212080" y="4888383"/>
             <a:ext cx="731520" cy="228600"/>
           </a:xfrm>
           <a:prstGeom prst="rect">
@@ -6534,28 +6651,28 @@
           <a:lstStyle/>
           <a:p>
             <a:pPr algn="ctr">
-              <a:defRPr sz="800" b="1">
-                <a:solidFill>
-                  <a:srgbClr val="2DD4A8"/>
-                </a:solidFill>
-                <a:latin typeface="Calibri"/>
-              </a:defRPr>
-            </a:pPr>
-            <a:r>
-              <a:t>3M</a:t>
-            </a:r>
-          </a:p>
-        </p:txBody>
-      </p:sp>
-      <p:sp>
-        <p:nvSpPr>
-          <p:cNvPr id="21" name="TextBox 20"/>
-          <p:cNvSpPr txBox="1"/>
-          <p:nvPr/>
-        </p:nvSpPr>
-        <p:spPr>
-          <a:xfrm>
-            <a:off x="4434840" y="5669280"/>
+              <a:defRPr sz="800" b="0">
+                <a:solidFill>
+                  <a:srgbClr val="999999"/>
+                </a:solidFill>
+                <a:latin typeface="Calibri"/>
+              </a:defRPr>
+            </a:pPr>
+            <a:r>
+              <a:t>4M</a:t>
+            </a:r>
+          </a:p>
+        </p:txBody>
+      </p:sp>
+      <p:sp>
+        <p:nvSpPr>
+          <p:cNvPr id="24" name="TextBox 23"/>
+          <p:cNvSpPr txBox="1"/>
+          <p:nvPr/>
+        </p:nvSpPr>
+        <p:spPr>
+          <a:xfrm>
+            <a:off x="5257800" y="5669280"/>
             <a:ext cx="640080" cy="228600"/>
           </a:xfrm>
           <a:prstGeom prst="rect">
@@ -6570,29 +6687,29 @@
           <a:lstStyle/>
           <a:p>
             <a:pPr algn="ctr">
-              <a:defRPr sz="800" b="1">
-                <a:solidFill>
-                  <a:srgbClr val="2DD4A8"/>
-                </a:solidFill>
-                <a:latin typeface="Calibri"/>
-              </a:defRPr>
-            </a:pPr>
-            <a:r>
-              <a:t>2030</a:t>
-            </a:r>
-          </a:p>
-        </p:txBody>
-      </p:sp>
-      <p:sp>
-        <p:nvSpPr>
-          <p:cNvPr id="22" name="Rounded Rectangle 21"/>
+              <a:defRPr sz="800" b="0">
+                <a:solidFill>
+                  <a:srgbClr val="666666"/>
+                </a:solidFill>
+                <a:latin typeface="Calibri"/>
+              </a:defRPr>
+            </a:pPr>
+            <a:r>
+              <a:t>2032</a:t>
+            </a:r>
+          </a:p>
+        </p:txBody>
+      </p:sp>
+      <p:sp>
+        <p:nvSpPr>
+          <p:cNvPr id="25" name="Rounded Rectangle 24"/>
           <p:cNvSpPr/>
           <p:nvPr/>
         </p:nvSpPr>
         <p:spPr>
           <a:xfrm>
-            <a:off x="5303520" y="5014570"/>
-            <a:ext cx="548640" cy="563270"/>
+            <a:off x="6126480" y="4297680"/>
+            <a:ext cx="548640" cy="1280160"/>
           </a:xfrm>
           <a:prstGeom prst="roundRect">
             <a:avLst>
@@ -6600,7 +6717,7 @@
             </a:avLst>
           </a:prstGeom>
           <a:solidFill>
-            <a:srgbClr val="2D604C"/>
+            <a:srgbClr val="2D896D"/>
           </a:solidFill>
           <a:ln>
             <a:noFill/>
@@ -6630,13 +6747,13 @@
       </p:sp>
       <p:sp>
         <p:nvSpPr>
-          <p:cNvPr id="23" name="TextBox 22"/>
-          <p:cNvSpPr txBox="1"/>
-          <p:nvPr/>
-        </p:nvSpPr>
-        <p:spPr>
-          <a:xfrm>
-            <a:off x="5212080" y="4785970"/>
+          <p:cNvPr id="26" name="TextBox 25"/>
+          <p:cNvSpPr txBox="1"/>
+          <p:nvPr/>
+        </p:nvSpPr>
+        <p:spPr>
+          <a:xfrm>
+            <a:off x="6035040" y="4069080"/>
             <a:ext cx="731520" cy="228600"/>
           </a:xfrm>
           <a:prstGeom prst="rect">
@@ -6659,124 +6776,7 @@
               </a:defRPr>
             </a:pPr>
             <a:r>
-              <a:t>6M</a:t>
-            </a:r>
-          </a:p>
-        </p:txBody>
-      </p:sp>
-      <p:sp>
-        <p:nvSpPr>
-          <p:cNvPr id="24" name="TextBox 23"/>
-          <p:cNvSpPr txBox="1"/>
-          <p:nvPr/>
-        </p:nvSpPr>
-        <p:spPr>
-          <a:xfrm>
-            <a:off x="5257800" y="5669280"/>
-            <a:ext cx="640080" cy="228600"/>
-          </a:xfrm>
-          <a:prstGeom prst="rect">
-            <a:avLst/>
-          </a:prstGeom>
-          <a:noFill/>
-        </p:spPr>
-        <p:txBody>
-          <a:bodyPr wrap="square">
-            <a:spAutoFit/>
-          </a:bodyPr>
-          <a:lstStyle/>
-          <a:p>
-            <a:pPr algn="ctr">
-              <a:defRPr sz="800" b="0">
-                <a:solidFill>
-                  <a:srgbClr val="666666"/>
-                </a:solidFill>
-                <a:latin typeface="Calibri"/>
-              </a:defRPr>
-            </a:pPr>
-            <a:r>
-              <a:t>2032</a:t>
-            </a:r>
-          </a:p>
-        </p:txBody>
-      </p:sp>
-      <p:sp>
-        <p:nvSpPr>
-          <p:cNvPr id="25" name="Rounded Rectangle 24"/>
-          <p:cNvSpPr/>
-          <p:nvPr/>
-        </p:nvSpPr>
-        <p:spPr>
-          <a:xfrm>
-            <a:off x="6126480" y="4041648"/>
-            <a:ext cx="548640" cy="1536192"/>
-          </a:xfrm>
-          <a:prstGeom prst="roundRect">
-            <a:avLst>
-              <a:gd name="adj" fmla="val 15000"/>
-            </a:avLst>
-          </a:prstGeom>
-          <a:solidFill>
-            <a:srgbClr val="2D9878"/>
-          </a:solidFill>
-          <a:ln>
-            <a:noFill/>
-          </a:ln>
-        </p:spPr>
-        <p:style>
-          <a:lnRef idx="1">
-            <a:schemeClr val="accent1"/>
-          </a:lnRef>
-          <a:fillRef idx="3">
-            <a:schemeClr val="accent1"/>
-          </a:fillRef>
-          <a:effectRef idx="2">
-            <a:schemeClr val="accent1"/>
-          </a:effectRef>
-          <a:fontRef idx="minor">
-            <a:schemeClr val="lt1"/>
-          </a:fontRef>
-        </p:style>
-        <p:txBody>
-          <a:bodyPr rtlCol="0" anchor="ctr"/>
-          <a:lstStyle/>
-          <a:p>
-            <a:pPr algn="ctr"/>
-          </a:p>
-        </p:txBody>
-      </p:sp>
-      <p:sp>
-        <p:nvSpPr>
-          <p:cNvPr id="26" name="TextBox 25"/>
-          <p:cNvSpPr txBox="1"/>
-          <p:nvPr/>
-        </p:nvSpPr>
-        <p:spPr>
-          <a:xfrm>
-            <a:off x="6035040" y="3813048"/>
-            <a:ext cx="731520" cy="228600"/>
-          </a:xfrm>
-          <a:prstGeom prst="rect">
-            <a:avLst/>
-          </a:prstGeom>
-          <a:noFill/>
-        </p:spPr>
-        <p:txBody>
-          <a:bodyPr wrap="square">
-            <a:spAutoFit/>
-          </a:bodyPr>
-          <a:lstStyle/>
-          <a:p>
-            <a:pPr algn="ctr">
-              <a:defRPr sz="800" b="0">
-                <a:solidFill>
-                  <a:srgbClr val="999999"/>
-                </a:solidFill>
-                <a:latin typeface="Calibri"/>
-              </a:defRPr>
-            </a:pPr>
-            <a:r>
-              <a:t>21M</a:t>
+              <a:t>15M</a:t>
             </a:r>
           </a:p>
         </p:txBody>
@@ -6893,7 +6893,7 @@
               </a:defRPr>
             </a:pPr>
             <a:r>
-              <a:t>73M</a:t>
+              <a:t>52M</a:t>
             </a:r>
           </a:p>
         </p:txBody>
@@ -7192,7 +7192,7 @@
               </a:defRPr>
             </a:pPr>
             <a:r>
-              <a:t>2029</a:t>
+              <a:t>2031</a:t>
             </a:r>
           </a:p>
         </p:txBody>
@@ -7228,7 +7228,7 @@
               </a:defRPr>
             </a:pPr>
             <a:r>
-              <a:t>Growth · 4,250 poles</a:t>
+              <a:t>110 ha complete</a:t>
             </a:r>
           </a:p>
         </p:txBody>
@@ -7264,7 +7264,7 @@
               </a:defRPr>
             </a:pPr>
             <a:r>
-              <a:t>2032</a:t>
+              <a:t>2033</a:t>
             </a:r>
           </a:p>
         </p:txBody>
@@ -7300,7 +7300,7 @@
               </a:defRPr>
             </a:pPr>
             <a:r>
-              <a:t>Cash-positive</a:t>
+              <a:t>Cash-positive cum.</a:t>
             </a:r>
           </a:p>
         </p:txBody>
@@ -7336,7 +7336,7 @@
               </a:defRPr>
             </a:pPr>
             <a:r>
-              <a:t>2031</a:t>
+              <a:t>2038</a:t>
             </a:r>
           </a:p>
         </p:txBody>
@@ -7372,7 +7372,7 @@
               </a:defRPr>
             </a:pPr>
             <a:r>
-              <a:t>110 ha complete</a:t>
+              <a:t>Full @ 1,400/ha</a:t>
             </a:r>
           </a:p>
         </p:txBody>
@@ -7408,7 +7408,7 @@
               </a:defRPr>
             </a:pPr>
             <a:r>
-              <a:t>2038</a:t>
+              <a:t>—</a:t>
             </a:r>
           </a:p>
         </p:txBody>
@@ -7444,7 +7444,7 @@
               </a:defRPr>
             </a:pPr>
             <a:r>
-              <a:t>Full maturity</a:t>
+              <a:t>154K poles/year</a:t>
             </a:r>
           </a:p>
         </p:txBody>
@@ -8079,7 +8079,7 @@
               </a:defRPr>
             </a:pPr>
             <a:r>
-              <a:t>36.5M MXN</a:t>
+              <a:t>37M MXN</a:t>
             </a:r>
           </a:p>
         </p:txBody>
@@ -8232,7 +8232,7 @@
               </a:defRPr>
             </a:pPr>
             <a:r>
-              <a:t>Still profitable</a:t>
+              <a:t>Downside protection</a:t>
             </a:r>
           </a:p>
         </p:txBody>
@@ -8358,7 +8358,7 @@
               </a:defRPr>
             </a:pPr>
             <a:r>
-              <a:t>BASE CASE</a:t>
+              <a:t>BASE CASE ⭐</a:t>
             </a:r>
           </a:p>
         </p:txBody>
@@ -8394,7 +8394,7 @@
               </a:defRPr>
             </a:pPr>
             <a:r>
-              <a:t>2,000</a:t>
+              <a:t>1,400</a:t>
             </a:r>
           </a:p>
         </p:txBody>
@@ -8502,7 +8502,7 @@
               </a:defRPr>
             </a:pPr>
             <a:r>
-              <a:t>21.3M MXN</a:t>
+              <a:t>15M MXN</a:t>
             </a:r>
           </a:p>
         </p:txBody>
@@ -8574,7 +8574,7 @@
               </a:defRPr>
             </a:pPr>
             <a:r>
-              <a:t>73M MXN</a:t>
+              <a:t>52M MXN</a:t>
             </a:r>
           </a:p>
         </p:txBody>
@@ -8640,13 +8640,13 @@
             <a:pPr algn="r">
               <a:defRPr sz="1000" b="1">
                 <a:solidFill>
-                  <a:srgbClr val="2DD4A8"/>
-                </a:solidFill>
-                <a:latin typeface="Calibri"/>
-              </a:defRPr>
-            </a:pPr>
-            <a:r>
-              <a:t>2032</a:t>
+                  <a:srgbClr val="FFFFFF"/>
+                </a:solidFill>
+                <a:latin typeface="Calibri"/>
+              </a:defRPr>
+            </a:pPr>
+            <a:r>
+              <a:t>2033</a:t>
             </a:r>
           </a:p>
         </p:txBody>
@@ -8727,7 +8727,7 @@
               </a:defRPr>
             </a:pPr>
             <a:r>
-              <a:t>Our projection</a:t>
+              <a:t>OUR PROJECTION</a:t>
             </a:r>
           </a:p>
         </p:txBody>
@@ -8889,7 +8889,7 @@
               </a:defRPr>
             </a:pPr>
             <a:r>
-              <a:t>3,000</a:t>
+              <a:t>2,000-3,000</a:t>
             </a:r>
           </a:p>
         </p:txBody>
@@ -8997,7 +8997,7 @@
               </a:defRPr>
             </a:pPr>
             <a:r>
-              <a:t>32M MXN</a:t>
+              <a:t>21-32M</a:t>
             </a:r>
           </a:p>
         </p:txBody>
@@ -9069,7 +9069,7 @@
               </a:defRPr>
             </a:pPr>
             <a:r>
-              <a:t>110M MXN</a:t>
+              <a:t>73-110M</a:t>
             </a:r>
           </a:p>
         </p:txBody>
@@ -9141,7 +9141,7 @@
               </a:defRPr>
             </a:pPr>
             <a:r>
-              <a:t>2031</a:t>
+              <a:t>2031-32</a:t>
             </a:r>
           </a:p>
         </p:txBody>
@@ -9258,7 +9258,7 @@
               </a:defRPr>
             </a:pPr>
             <a:r>
-              <a:t>Key assumptions: 400 MXN/pole · 15% waste · 110 ha (50 own + 60 leased) · Smooth planting 2027-2031. Only yield varies.</a:t>
+              <a:t>CONSERVATIVE BASE: 1,400 poles/ha (not 2,000). Key assumptions: 400 MXN/pole · 15% waste · 110 ha (50 own + 60 leased). Only yield varies.</a:t>
             </a:r>
           </a:p>
         </p:txBody>
@@ -13531,7 +13531,7 @@
               </a:defRPr>
             </a:pPr>
             <a:r>
-              <a:t>First profitable year. 6.5M MXN revenue. Vehicle purchases begin. Dividends planning starts.</a:t>
+              <a:t>First profitable year. 4.1M MXN revenue. Vehicle purchases begin. Dividends planning starts.</a:t>
             </a:r>
           </a:p>
         </p:txBody>
@@ -13650,7 +13650,7 @@
               </a:defRPr>
             </a:pPr>
             <a:r>
-              <a:t>All 110 ha producing. Revenue scales 11M → 73M MXN. Big bodega 2034. ICC-ES 2037 (1yr before full maturity).</a:t>
+              <a:t>All 110 ha producing. Revenue scales to 52M MXN (at 1,400/ha base). Big bodega 2034. ICC-ES 2037.</a:t>
             </a:r>
           </a:p>
         </p:txBody>
@@ -13748,7 +13748,7 @@
               </a:defRPr>
             </a:pPr>
             <a:r>
-              <a:t>180,000+ poles/year at full maturity · Replicable model</a:t>
+              <a:t>154,000 poles/year at full maturity · Replicable to 200+ ha</a:t>
             </a:r>
           </a:p>
         </p:txBody>

</xml_diff>

<commit_message>
Rename 'The Ask' → 'Funding Plan & Structure'; fix PPTX inaccuracies
HTML + PPTX title change:
- Section label: Investment Opportunity → CAPITAL RAISE
- Slide title: The Ask → Funding Plan & Structure (more professional)

PPTX inaccuracies fixed:
- Cash-positive year: 2030 → 2032 (Financial Projections slide highlight)
- Round 1: 14% → 12% equity in 3 tranches (was single lump)
  * Pre/post-money: 28.5M → 33.3M
- Round 2: 2.5M@6% → 5M@9%
  * Pre/post-money: 41.5M → 55.6M
  * Use: 50% ops + 50% marketing (Ofir-led export push)
- Equity allocation table: 12% R1 + 9% R2 + 4% reserve + 15% Ofir + 60% founders
- Milestone roadmap: Round 2 description and 2032 revenue corrected

Co-Authored-By: Claude Opus 4.6 (1M context) <noreply@anthropic.com>
</commit_message>
<xml_diff>
--- a/Pacifico_Bambu_Pitch_Deck_v3.pptx
+++ b/Pacifico_Bambu_Pitch_Deck_v3.pptx
@@ -6534,9 +6534,9 @@
           <a:lstStyle/>
           <a:p>
             <a:pPr algn="ctr">
-              <a:defRPr sz="800" b="1">
-                <a:solidFill>
-                  <a:srgbClr val="2DD4A8"/>
+              <a:defRPr sz="800" b="0">
+                <a:solidFill>
+                  <a:srgbClr val="999999"/>
                 </a:solidFill>
                 <a:latin typeface="Calibri"/>
               </a:defRPr>
@@ -6570,9 +6570,9 @@
           <a:lstStyle/>
           <a:p>
             <a:pPr algn="ctr">
-              <a:defRPr sz="800" b="1">
-                <a:solidFill>
-                  <a:srgbClr val="2DD4A8"/>
+              <a:defRPr sz="800" b="0">
+                <a:solidFill>
+                  <a:srgbClr val="666666"/>
                 </a:solidFill>
                 <a:latin typeface="Calibri"/>
               </a:defRPr>
@@ -6651,9 +6651,9 @@
           <a:lstStyle/>
           <a:p>
             <a:pPr algn="ctr">
-              <a:defRPr sz="800" b="0">
-                <a:solidFill>
-                  <a:srgbClr val="999999"/>
+              <a:defRPr sz="800" b="1">
+                <a:solidFill>
+                  <a:srgbClr val="2DD4A8"/>
                 </a:solidFill>
                 <a:latin typeface="Calibri"/>
               </a:defRPr>
@@ -6687,9 +6687,9 @@
           <a:lstStyle/>
           <a:p>
             <a:pPr algn="ctr">
-              <a:defRPr sz="800" b="0">
-                <a:solidFill>
-                  <a:srgbClr val="666666"/>
+              <a:defRPr sz="800" b="1">
+                <a:solidFill>
+                  <a:srgbClr val="2DD4A8"/>
                 </a:solidFill>
                 <a:latin typeface="Calibri"/>
               </a:defRPr>
@@ -6885,9 +6885,9 @@
           <a:lstStyle/>
           <a:p>
             <a:pPr algn="ctr">
-              <a:defRPr sz="800" b="0">
-                <a:solidFill>
-                  <a:srgbClr val="999999"/>
+              <a:defRPr sz="800" b="1">
+                <a:solidFill>
+                  <a:srgbClr val="2DD4A8"/>
                 </a:solidFill>
                 <a:latin typeface="Calibri"/>
               </a:defRPr>
@@ -6921,9 +6921,9 @@
           <a:lstStyle/>
           <a:p>
             <a:pPr algn="ctr">
-              <a:defRPr sz="800" b="0">
-                <a:solidFill>
-                  <a:srgbClr val="666666"/>
+              <a:defRPr sz="800" b="1">
+                <a:solidFill>
+                  <a:srgbClr val="2DD4A8"/>
                 </a:solidFill>
                 <a:latin typeface="Calibri"/>
               </a:defRPr>
@@ -9320,7 +9320,7 @@
               </a:defRPr>
             </a:pPr>
             <a:r>
-              <a:t>INVESTMENT OPPORTUNITY</a:t>
+              <a:t>CAPITAL RAISE</a:t>
             </a:r>
           </a:p>
         </p:txBody>
@@ -9356,7 +9356,7 @@
               </a:defRPr>
             </a:pPr>
             <a:r>
-              <a:t>The Ask</a:t>
+              <a:t>Funding Plan &amp; Structure</a:t>
             </a:r>
           </a:p>
         </p:txBody>
@@ -9392,7 +9392,7 @@
               </a:defRPr>
             </a:pPr>
             <a:r>
-              <a:t>20% equity reserved for investors. First tranche at the highest-risk early valuation.</a:t>
+              <a:t>Two rounds, 25% total equity ceiling. Round 1 in 3 milestone-based tranches — investor protection built in.</a:t>
             </a:r>
           </a:p>
         </p:txBody>
@@ -9547,7 +9547,7 @@
               </a:defRPr>
             </a:pPr>
             <a:r>
-              <a:t>MXN for 14% equity</a:t>
+              <a:t>MXN for 12% equity (3 tranches)</a:t>
             </a:r>
           </a:p>
         </p:txBody>
@@ -9583,7 +9583,7 @@
               </a:defRPr>
             </a:pPr>
             <a:r>
-              <a:t>Pre-money: ~24.5M MXN · Post-money: ~28.5M MXN</a:t>
+              <a:t>Pre-money: ~29.3M MXN · Post-money: ~33.3M MXN</a:t>
             </a:r>
           </a:p>
         </p:txBody>
@@ -9655,7 +9655,7 @@
               </a:defRPr>
             </a:pPr>
             <a:r>
-              <a:t>4-year runway: ops to end-2029</a:t>
+              <a:t>Tranche 1 (signing): 2026 + Q1 2027</a:t>
             </a:r>
           </a:p>
         </p:txBody>
@@ -9691,7 +9691,7 @@
               </a:defRPr>
             </a:pPr>
             <a:r>
-              <a:t>45%</a:t>
+              <a:t>37%</a:t>
             </a:r>
           </a:p>
         </p:txBody>
@@ -9750,7 +9750,7 @@
         <p:spPr>
           <a:xfrm>
             <a:off x="1005840" y="4663440"/>
-            <a:ext cx="1975104" cy="109728"/>
+            <a:ext cx="1645919" cy="109728"/>
           </a:xfrm>
           <a:prstGeom prst="roundRect">
             <a:avLst>
@@ -9817,7 +9817,7 @@
               </a:defRPr>
             </a:pPr>
             <a:r>
-              <a:t>Land prep + planting 50 own ha</a:t>
+              <a:t>Tranche 2 (Q2 2027): Q2-Q4 2027</a:t>
             </a:r>
           </a:p>
         </p:txBody>
@@ -9979,7 +9979,7 @@
               </a:defRPr>
             </a:pPr>
             <a:r>
-              <a:t>Mgmt salaries (start 2027)</a:t>
+              <a:t>Tranche 3 (Q1 2028): until Round 2</a:t>
             </a:r>
           </a:p>
         </p:txBody>
@@ -10015,7 +10015,7 @@
               </a:defRPr>
             </a:pPr>
             <a:r>
-              <a:t>20%</a:t>
+              <a:t>37%</a:t>
             </a:r>
           </a:p>
         </p:txBody>
@@ -10074,7 +10074,7 @@
         <p:spPr>
           <a:xfrm>
             <a:off x="1005840" y="5431536"/>
-            <a:ext cx="877824" cy="109728"/>
+            <a:ext cx="1645919" cy="109728"/>
           </a:xfrm>
           <a:prstGeom prst="roundRect">
             <a:avLst>
@@ -10141,7 +10141,7 @@
               </a:defRPr>
             </a:pPr>
             <a:r>
-              <a:t>Bodegas, pools, infrastructure</a:t>
+              <a:t>All milestone-based (poles sold, ha)</a:t>
             </a:r>
           </a:p>
         </p:txBody>
@@ -10177,7 +10177,7 @@
               </a:defRPr>
             </a:pPr>
             <a:r>
-              <a:t>10%</a:t>
+              <a:t>0%</a:t>
             </a:r>
           </a:p>
         </p:txBody>
@@ -10236,7 +10236,7 @@
         <p:spPr>
           <a:xfrm>
             <a:off x="1005840" y="5815584"/>
-            <a:ext cx="438912" cy="109728"/>
+            <a:ext cx="0" cy="109728"/>
           </a:xfrm>
           <a:prstGeom prst="roundRect">
             <a:avLst>
@@ -10503,7 +10503,7 @@
               </a:defRPr>
             </a:pPr>
             <a:r>
-              <a:t>Investors total (R1+R2)</a:t>
+              <a:t>Round 1 (Bridge)</a:t>
             </a:r>
           </a:p>
         </p:txBody>
@@ -10517,7 +10517,7 @@
         <p:spPr>
           <a:xfrm>
             <a:off x="9326880" y="3383280"/>
-            <a:ext cx="731520" cy="182880"/>
+            <a:ext cx="438912" cy="182880"/>
           </a:xfrm>
           <a:prstGeom prst="roundRect">
             <a:avLst>
@@ -10561,7 +10561,7 @@
         </p:nvSpPr>
         <p:spPr>
           <a:xfrm>
-            <a:off x="10149840" y="3364992"/>
+            <a:off x="9857232" y="3364992"/>
             <a:ext cx="548640" cy="228600"/>
           </a:xfrm>
           <a:prstGeom prst="rect">
@@ -10584,7 +10584,7 @@
               </a:defRPr>
             </a:pPr>
             <a:r>
-              <a:t>20%</a:t>
+              <a:t>12%</a:t>
             </a:r>
           </a:p>
         </p:txBody>
@@ -10620,7 +10620,7 @@
               </a:defRPr>
             </a:pPr>
             <a:r>
-              <a:t>Managing Partner (vested)</a:t>
+              <a:t>Round 2 (Seed 2028)</a:t>
             </a:r>
           </a:p>
         </p:txBody>
@@ -10634,6 +10634,240 @@
         <p:spPr>
           <a:xfrm>
             <a:off x="9326880" y="3840480"/>
+            <a:ext cx="329184" cy="182880"/>
+          </a:xfrm>
+          <a:prstGeom prst="roundRect">
+            <a:avLst>
+              <a:gd name="adj" fmla="val 50000"/>
+            </a:avLst>
+          </a:prstGeom>
+          <a:solidFill>
+            <a:srgbClr val="60A5FA"/>
+          </a:solidFill>
+          <a:ln>
+            <a:noFill/>
+          </a:ln>
+        </p:spPr>
+        <p:style>
+          <a:lnRef idx="1">
+            <a:schemeClr val="accent1"/>
+          </a:lnRef>
+          <a:fillRef idx="3">
+            <a:schemeClr val="accent1"/>
+          </a:fillRef>
+          <a:effectRef idx="2">
+            <a:schemeClr val="accent1"/>
+          </a:effectRef>
+          <a:fontRef idx="minor">
+            <a:schemeClr val="lt1"/>
+          </a:fontRef>
+        </p:style>
+        <p:txBody>
+          <a:bodyPr rtlCol="0" anchor="ctr"/>
+          <a:lstStyle/>
+          <a:p>
+            <a:pPr algn="ctr"/>
+          </a:p>
+        </p:txBody>
+      </p:sp>
+      <p:sp>
+        <p:nvSpPr>
+          <p:cNvPr id="37" name="TextBox 36"/>
+          <p:cNvSpPr txBox="1"/>
+          <p:nvPr/>
+        </p:nvSpPr>
+        <p:spPr>
+          <a:xfrm>
+            <a:off x="9747504" y="3822192"/>
+            <a:ext cx="548640" cy="228600"/>
+          </a:xfrm>
+          <a:prstGeom prst="rect">
+            <a:avLst/>
+          </a:prstGeom>
+          <a:noFill/>
+        </p:spPr>
+        <p:txBody>
+          <a:bodyPr wrap="square">
+            <a:spAutoFit/>
+          </a:bodyPr>
+          <a:lstStyle/>
+          <a:p>
+            <a:pPr algn="l">
+              <a:defRPr sz="1000" b="1">
+                <a:solidFill>
+                  <a:srgbClr val="FFFFFF"/>
+                </a:solidFill>
+                <a:latin typeface="Calibri"/>
+              </a:defRPr>
+            </a:pPr>
+            <a:r>
+              <a:t>9%</a:t>
+            </a:r>
+          </a:p>
+        </p:txBody>
+      </p:sp>
+      <p:sp>
+        <p:nvSpPr>
+          <p:cNvPr id="38" name="TextBox 37"/>
+          <p:cNvSpPr txBox="1"/>
+          <p:nvPr/>
+        </p:nvSpPr>
+        <p:spPr>
+          <a:xfrm>
+            <a:off x="6858000" y="4297680"/>
+            <a:ext cx="2286000" cy="228600"/>
+          </a:xfrm>
+          <a:prstGeom prst="rect">
+            <a:avLst/>
+          </a:prstGeom>
+          <a:noFill/>
+        </p:spPr>
+        <p:txBody>
+          <a:bodyPr wrap="square">
+            <a:spAutoFit/>
+          </a:bodyPr>
+          <a:lstStyle/>
+          <a:p>
+            <a:pPr algn="l">
+              <a:defRPr sz="1000" b="0">
+                <a:solidFill>
+                  <a:srgbClr val="999999"/>
+                </a:solidFill>
+                <a:latin typeface="Calibri"/>
+              </a:defRPr>
+            </a:pPr>
+            <a:r>
+              <a:t>Future investors/talent</a:t>
+            </a:r>
+          </a:p>
+        </p:txBody>
+      </p:sp>
+      <p:sp>
+        <p:nvSpPr>
+          <p:cNvPr id="39" name="Rounded Rectangle 38"/>
+          <p:cNvSpPr/>
+          <p:nvPr/>
+        </p:nvSpPr>
+        <p:spPr>
+          <a:xfrm>
+            <a:off x="9326880" y="4297680"/>
+            <a:ext cx="146304" cy="182880"/>
+          </a:xfrm>
+          <a:prstGeom prst="roundRect">
+            <a:avLst>
+              <a:gd name="adj" fmla="val 50000"/>
+            </a:avLst>
+          </a:prstGeom>
+          <a:solidFill>
+            <a:srgbClr val="666666"/>
+          </a:solidFill>
+          <a:ln>
+            <a:noFill/>
+          </a:ln>
+        </p:spPr>
+        <p:style>
+          <a:lnRef idx="1">
+            <a:schemeClr val="accent1"/>
+          </a:lnRef>
+          <a:fillRef idx="3">
+            <a:schemeClr val="accent1"/>
+          </a:fillRef>
+          <a:effectRef idx="2">
+            <a:schemeClr val="accent1"/>
+          </a:effectRef>
+          <a:fontRef idx="minor">
+            <a:schemeClr val="lt1"/>
+          </a:fontRef>
+        </p:style>
+        <p:txBody>
+          <a:bodyPr rtlCol="0" anchor="ctr"/>
+          <a:lstStyle/>
+          <a:p>
+            <a:pPr algn="ctr"/>
+          </a:p>
+        </p:txBody>
+      </p:sp>
+      <p:sp>
+        <p:nvSpPr>
+          <p:cNvPr id="40" name="TextBox 39"/>
+          <p:cNvSpPr txBox="1"/>
+          <p:nvPr/>
+        </p:nvSpPr>
+        <p:spPr>
+          <a:xfrm>
+            <a:off x="9564624" y="4279392"/>
+            <a:ext cx="548640" cy="228600"/>
+          </a:xfrm>
+          <a:prstGeom prst="rect">
+            <a:avLst/>
+          </a:prstGeom>
+          <a:noFill/>
+        </p:spPr>
+        <p:txBody>
+          <a:bodyPr wrap="square">
+            <a:spAutoFit/>
+          </a:bodyPr>
+          <a:lstStyle/>
+          <a:p>
+            <a:pPr algn="l">
+              <a:defRPr sz="1000" b="1">
+                <a:solidFill>
+                  <a:srgbClr val="FFFFFF"/>
+                </a:solidFill>
+                <a:latin typeface="Calibri"/>
+              </a:defRPr>
+            </a:pPr>
+            <a:r>
+              <a:t>4%</a:t>
+            </a:r>
+          </a:p>
+        </p:txBody>
+      </p:sp>
+      <p:sp>
+        <p:nvSpPr>
+          <p:cNvPr id="41" name="TextBox 40"/>
+          <p:cNvSpPr txBox="1"/>
+          <p:nvPr/>
+        </p:nvSpPr>
+        <p:spPr>
+          <a:xfrm>
+            <a:off x="6858000" y="4754880"/>
+            <a:ext cx="2286000" cy="228600"/>
+          </a:xfrm>
+          <a:prstGeom prst="rect">
+            <a:avLst/>
+          </a:prstGeom>
+          <a:noFill/>
+        </p:spPr>
+        <p:txBody>
+          <a:bodyPr wrap="square">
+            <a:spAutoFit/>
+          </a:bodyPr>
+          <a:lstStyle/>
+          <a:p>
+            <a:pPr algn="l">
+              <a:defRPr sz="1000" b="0">
+                <a:solidFill>
+                  <a:srgbClr val="999999"/>
+                </a:solidFill>
+                <a:latin typeface="Calibri"/>
+              </a:defRPr>
+            </a:pPr>
+            <a:r>
+              <a:t>Managing Partner (vested)</a:t>
+            </a:r>
+          </a:p>
+        </p:txBody>
+      </p:sp>
+      <p:sp>
+        <p:nvSpPr>
+          <p:cNvPr id="42" name="Rounded Rectangle 41"/>
+          <p:cNvSpPr/>
+          <p:nvPr/>
+        </p:nvSpPr>
+        <p:spPr>
+          <a:xfrm>
+            <a:off x="9326880" y="4754880"/>
             <a:ext cx="548640" cy="182880"/>
           </a:xfrm>
           <a:prstGeom prst="roundRect">
@@ -10672,13 +10906,13 @@
       </p:sp>
       <p:sp>
         <p:nvSpPr>
-          <p:cNvPr id="37" name="TextBox 36"/>
-          <p:cNvSpPr txBox="1"/>
-          <p:nvPr/>
-        </p:nvSpPr>
-        <p:spPr>
-          <a:xfrm>
-            <a:off x="9966960" y="3822192"/>
+          <p:cNvPr id="43" name="TextBox 42"/>
+          <p:cNvSpPr txBox="1"/>
+          <p:nvPr/>
+        </p:nvSpPr>
+        <p:spPr>
+          <a:xfrm>
+            <a:off x="9966960" y="4736592"/>
             <a:ext cx="548640" cy="228600"/>
           </a:xfrm>
           <a:prstGeom prst="rect">
@@ -10708,124 +10942,7 @@
       </p:sp>
       <p:sp>
         <p:nvSpPr>
-          <p:cNvPr id="38" name="TextBox 37"/>
-          <p:cNvSpPr txBox="1"/>
-          <p:nvPr/>
-        </p:nvSpPr>
-        <p:spPr>
-          <a:xfrm>
-            <a:off x="6858000" y="4297680"/>
-            <a:ext cx="2286000" cy="228600"/>
-          </a:xfrm>
-          <a:prstGeom prst="rect">
-            <a:avLst/>
-          </a:prstGeom>
-          <a:noFill/>
-        </p:spPr>
-        <p:txBody>
-          <a:bodyPr wrap="square">
-            <a:spAutoFit/>
-          </a:bodyPr>
-          <a:lstStyle/>
-          <a:p>
-            <a:pPr algn="l">
-              <a:defRPr sz="1000" b="0">
-                <a:solidFill>
-                  <a:srgbClr val="999999"/>
-                </a:solidFill>
-                <a:latin typeface="Calibri"/>
-              </a:defRPr>
-            </a:pPr>
-            <a:r>
-              <a:t>Strategic reserve</a:t>
-            </a:r>
-          </a:p>
-        </p:txBody>
-      </p:sp>
-      <p:sp>
-        <p:nvSpPr>
-          <p:cNvPr id="39" name="Rounded Rectangle 38"/>
-          <p:cNvSpPr/>
-          <p:nvPr/>
-        </p:nvSpPr>
-        <p:spPr>
-          <a:xfrm>
-            <a:off x="9326880" y="4297680"/>
-            <a:ext cx="182880" cy="182880"/>
-          </a:xfrm>
-          <a:prstGeom prst="roundRect">
-            <a:avLst>
-              <a:gd name="adj" fmla="val 50000"/>
-            </a:avLst>
-          </a:prstGeom>
-          <a:solidFill>
-            <a:srgbClr val="666666"/>
-          </a:solidFill>
-          <a:ln>
-            <a:noFill/>
-          </a:ln>
-        </p:spPr>
-        <p:style>
-          <a:lnRef idx="1">
-            <a:schemeClr val="accent1"/>
-          </a:lnRef>
-          <a:fillRef idx="3">
-            <a:schemeClr val="accent1"/>
-          </a:fillRef>
-          <a:effectRef idx="2">
-            <a:schemeClr val="accent1"/>
-          </a:effectRef>
-          <a:fontRef idx="minor">
-            <a:schemeClr val="lt1"/>
-          </a:fontRef>
-        </p:style>
-        <p:txBody>
-          <a:bodyPr rtlCol="0" anchor="ctr"/>
-          <a:lstStyle/>
-          <a:p>
-            <a:pPr algn="ctr"/>
-          </a:p>
-        </p:txBody>
-      </p:sp>
-      <p:sp>
-        <p:nvSpPr>
-          <p:cNvPr id="40" name="TextBox 39"/>
-          <p:cNvSpPr txBox="1"/>
-          <p:nvPr/>
-        </p:nvSpPr>
-        <p:spPr>
-          <a:xfrm>
-            <a:off x="9601200" y="4279392"/>
-            <a:ext cx="548640" cy="228600"/>
-          </a:xfrm>
-          <a:prstGeom prst="rect">
-            <a:avLst/>
-          </a:prstGeom>
-          <a:noFill/>
-        </p:spPr>
-        <p:txBody>
-          <a:bodyPr wrap="square">
-            <a:spAutoFit/>
-          </a:bodyPr>
-          <a:lstStyle/>
-          <a:p>
-            <a:pPr algn="l">
-              <a:defRPr sz="1000" b="1">
-                <a:solidFill>
-                  <a:srgbClr val="FFFFFF"/>
-                </a:solidFill>
-                <a:latin typeface="Calibri"/>
-              </a:defRPr>
-            </a:pPr>
-            <a:r>
-              <a:t>5%</a:t>
-            </a:r>
-          </a:p>
-        </p:txBody>
-      </p:sp>
-      <p:sp>
-        <p:nvSpPr>
-          <p:cNvPr id="41" name="TextBox 40"/>
+          <p:cNvPr id="44" name="TextBox 43"/>
           <p:cNvSpPr txBox="1"/>
           <p:nvPr/>
         </p:nvSpPr>
@@ -10854,14 +10971,14 @@
               </a:defRPr>
             </a:pPr>
             <a:r>
-              <a:t>Bridge investor takes 14% — the largest piece. Funds 2026-2029 operations completely. Round 2 (Seed) closes 2028 at significantly higher valuation.</a:t>
-            </a:r>
-          </a:p>
-        </p:txBody>
-      </p:sp>
-      <p:sp>
-        <p:nvSpPr>
-          <p:cNvPr id="42" name="Rounded Rectangle 41"/>
+              <a:t>Hard ceiling: 25% total investor equity. Round 1 at 12% in 3 tranches (milestone-gated). 4% reserved for future investors or talent hires.</a:t>
+            </a:r>
+          </a:p>
+        </p:txBody>
+      </p:sp>
+      <p:sp>
+        <p:nvSpPr>
+          <p:cNvPr id="45" name="Rounded Rectangle 44"/>
           <p:cNvSpPr/>
           <p:nvPr/>
         </p:nvSpPr>
@@ -10908,7 +11025,7 @@
       </p:sp>
       <p:sp>
         <p:nvSpPr>
-          <p:cNvPr id="43" name="TextBox 42"/>
+          <p:cNvPr id="46" name="TextBox 45"/>
           <p:cNvSpPr txBox="1"/>
           <p:nvPr/>
         </p:nvSpPr>
@@ -10944,7 +11061,7 @@
       </p:sp>
       <p:sp>
         <p:nvSpPr>
-          <p:cNvPr id="44" name="TextBox 43"/>
+          <p:cNvPr id="47" name="TextBox 46"/>
           <p:cNvSpPr txBox="1"/>
           <p:nvPr/>
         </p:nvSpPr>
@@ -10980,7 +11097,7 @@
       </p:sp>
       <p:sp>
         <p:nvSpPr>
-          <p:cNvPr id="45" name="Rounded Rectangle 44"/>
+          <p:cNvPr id="48" name="Rounded Rectangle 47"/>
           <p:cNvSpPr/>
           <p:nvPr/>
         </p:nvSpPr>
@@ -11027,7 +11144,7 @@
       </p:sp>
       <p:sp>
         <p:nvSpPr>
-          <p:cNvPr id="46" name="TextBox 45"/>
+          <p:cNvPr id="49" name="TextBox 48"/>
           <p:cNvSpPr txBox="1"/>
           <p:nvPr/>
         </p:nvSpPr>
@@ -11309,7 +11426,7 @@
               </a:defRPr>
             </a:pPr>
             <a:r>
-              <a:t>2,500,000 MXN for ~6% equity</a:t>
+              <a:t>5,000,000 MXN for 9% equity</a:t>
             </a:r>
           </a:p>
         </p:txBody>
@@ -11896,7 +12013,7 @@
               </a:defRPr>
             </a:pPr>
             <a:r>
-              <a:t>Smaller raise = less dilution; founders keep more equity</a:t>
+              <a:t>5M raise enables marketing investment + US market entry</a:t>
             </a:r>
           </a:p>
         </p:txBody>
@@ -12051,7 +12168,7 @@
               </a:defRPr>
             </a:pPr>
             <a:r>
-              <a:t>28.5M MXN</a:t>
+              <a:t>33.3M MXN</a:t>
             </a:r>
           </a:p>
         </p:txBody>
@@ -12123,7 +12240,7 @@
               </a:defRPr>
             </a:pPr>
             <a:r>
-              <a:t>~41.5M MXN</a:t>
+              <a:t>~55.6M MXN</a:t>
             </a:r>
           </a:p>
         </p:txBody>
@@ -13293,7 +13410,7 @@
               </a:defRPr>
             </a:pPr>
             <a:r>
-              <a:t>Close 2.5M Seed at higher valuation (~41.5M post). 2 years of production data. 25 ha already planted. Funds next 4 years.</a:t>
+              <a:t>Close 5M Seed at ~55.6M post-money. 2 years of production data. 25 ha already planted. 50% ops + 50% marketing/export.</a:t>
             </a:r>
           </a:p>
         </p:txBody>
@@ -13531,7 +13648,7 @@
               </a:defRPr>
             </a:pPr>
             <a:r>
-              <a:t>First profitable year. 4.1M MXN revenue. Vehicle purchases begin. Dividends planning starts.</a:t>
+              <a:t>First profitable year. 5.9M MXN revenue. Vehicle purchases begin. Dividends planning starts.</a:t>
             </a:r>
           </a:p>
         </p:txBody>

</xml_diff>